<commit_message>
update teammate names across docs, receipts, and presentation slides
</commit_message>
<xml_diff>
--- a/docs/week-07/BrewMellow_Midterm_Presentation.pptx
+++ b/docs/week-07/BrewMellow_Midterm_Presentation.pptx
@@ -1777,6 +1777,10 @@
           </a:solidFill>
           <a:ln/>
         </p:spPr>
+        <p:txBody>
+          <a:bodyPr/>
+          <a:p/>
+        </p:txBody>
       </p:sp>
       <p:sp>
         <p:nvSpPr>
@@ -1825,6 +1829,10 @@
           </a:solidFill>
           <a:ln/>
         </p:spPr>
+        <p:txBody>
+          <a:bodyPr/>
+          <a:p/>
+        </p:txBody>
       </p:sp>
       <p:sp>
         <p:nvSpPr>
@@ -1856,15 +1864,7 @@
               <a:buNone/>
             </a:pPr>
             <a:r>
-              <a:rPr lang="en-US" sz="1500" b="1" dirty="0">
-                <a:solidFill>
-                  <a:srgbClr val="FAF8F5"/>
-                </a:solidFill>
-                <a:latin typeface="Arial" pitchFamily="34" charset="0"/>
-                <a:ea typeface="Arial" pitchFamily="34" charset="-122"/>
-                <a:cs typeface="Arial" pitchFamily="34" charset="-120"/>
-              </a:rPr>
-              <a:t>Aanchal ch. Thakuri</a:t>
+              <a:t>Aanchal Chand Thakuri</a:t>
             </a:r>
             <a:endParaRPr lang="en-US" sz="1500" dirty="0"/>
           </a:p>
@@ -1935,6 +1935,10 @@
           </a:solidFill>
           <a:ln/>
         </p:spPr>
+        <p:txBody>
+          <a:bodyPr/>
+          <a:p/>
+        </p:txBody>
       </p:sp>
       <p:sp>
         <p:nvSpPr>
@@ -1983,6 +1987,10 @@
           </a:solidFill>
           <a:ln/>
         </p:spPr>
+        <p:txBody>
+          <a:bodyPr/>
+          <a:p/>
+        </p:txBody>
       </p:sp>
       <p:sp>
         <p:nvSpPr>
@@ -2093,6 +2101,10 @@
           </a:solidFill>
           <a:ln/>
         </p:spPr>
+        <p:txBody>
+          <a:bodyPr/>
+          <a:p/>
+        </p:txBody>
       </p:sp>
       <p:sp>
         <p:nvSpPr>
@@ -2141,6 +2153,10 @@
           </a:solidFill>
           <a:ln/>
         </p:spPr>
+        <p:txBody>
+          <a:bodyPr/>
+          <a:p/>
+        </p:txBody>
       </p:sp>
       <p:sp>
         <p:nvSpPr>
@@ -2262,6 +2278,10 @@
           </a:solidFill>
           <a:ln/>
         </p:spPr>
+        <p:txBody>
+          <a:bodyPr/>
+          <a:p/>
+        </p:txBody>
       </p:sp>
       <p:sp>
         <p:nvSpPr>
@@ -2310,6 +2330,10 @@
           </a:solidFill>
           <a:ln/>
         </p:spPr>
+        <p:txBody>
+          <a:bodyPr/>
+          <a:p/>
+        </p:txBody>
       </p:sp>
       <p:sp>
         <p:nvSpPr>
@@ -2341,26 +2365,7 @@
               <a:buNone/>
             </a:pPr>
             <a:r>
-              <a:rPr lang="en-US" sz="1500" b="1" dirty="0">
-                <a:solidFill>
-                  <a:srgbClr val="FAF8F5"/>
-                </a:solidFill>
-                <a:latin typeface="Arial" pitchFamily="34" charset="0"/>
-                <a:ea typeface="Arial" pitchFamily="34" charset="-122"/>
-                <a:cs typeface="Arial" pitchFamily="34" charset="-120"/>
-              </a:rPr>
-              <a:t>Rohit </a:t>
-            </a:r>
-            <a:r>
-              <a:rPr lang="en-US" sz="1500" b="1" dirty="0" err="1">
-                <a:solidFill>
-                  <a:srgbClr val="FAF8F5"/>
-                </a:solidFill>
-                <a:latin typeface="Arial" pitchFamily="34" charset="0"/>
-                <a:ea typeface="Arial" pitchFamily="34" charset="-122"/>
-                <a:cs typeface="Arial" pitchFamily="34" charset="-120"/>
-              </a:rPr>
-              <a:t>Chantiyal</a:t>
+              <a:t>Rohit Chhantiyal</a:t>
             </a:r>
             <a:endParaRPr lang="en-US" sz="1500" dirty="0"/>
           </a:p>
@@ -2628,6 +2633,10 @@
           </a:solidFill>
           <a:ln/>
         </p:spPr>
+        <p:txBody>
+          <a:bodyPr/>
+          <a:p/>
+        </p:txBody>
       </p:sp>
       <p:sp>
         <p:nvSpPr>
@@ -2825,6 +2834,10 @@
           </a:solidFill>
           <a:ln/>
         </p:spPr>
+        <p:txBody>
+          <a:bodyPr/>
+          <a:p/>
+        </p:txBody>
       </p:sp>
       <p:sp>
         <p:nvSpPr>
@@ -3106,15 +3119,7 @@
               <a:buNone/>
             </a:pPr>
             <a:r>
-              <a:rPr lang="en-US" sz="1200" b="1" dirty="0">
-                <a:solidFill>
-                  <a:srgbClr val="1A1512"/>
-                </a:solidFill>
-                <a:latin typeface="Arial" pitchFamily="34" charset="0"/>
-                <a:ea typeface="Arial" pitchFamily="34" charset="-122"/>
-                <a:cs typeface="Arial" pitchFamily="34" charset="-120"/>
-              </a:rPr>
-              <a:t>Aanchal Thakuri · @jaasly07</a:t>
+              <a:t>Aanchal Chand Thakuri · @jaasly07</a:t>
             </a:r>
             <a:endParaRPr lang="en-US" sz="1200" dirty="0"/>
           </a:p>
@@ -3271,6 +3276,10 @@
             <a:prstDash val="solid"/>
           </a:ln>
         </p:spPr>
+        <p:txBody>
+          <a:bodyPr/>
+          <a:p/>
+        </p:txBody>
       </p:sp>
       <p:sp>
         <p:nvSpPr>
@@ -3606,6 +3615,10 @@
             <a:prstDash val="solid"/>
           </a:ln>
         </p:spPr>
+        <p:txBody>
+          <a:bodyPr/>
+          <a:p/>
+        </p:txBody>
       </p:sp>
       <p:sp>
         <p:nvSpPr>
@@ -4113,6 +4126,10 @@
           </a:solidFill>
           <a:ln/>
         </p:spPr>
+        <p:txBody>
+          <a:bodyPr/>
+          <a:p/>
+        </p:txBody>
       </p:sp>
       <p:sp>
         <p:nvSpPr>
@@ -4267,6 +4284,10 @@
           </a:solidFill>
           <a:ln/>
         </p:spPr>
+        <p:txBody>
+          <a:bodyPr/>
+          <a:p/>
+        </p:txBody>
       </p:sp>
       <p:sp>
         <p:nvSpPr>
@@ -4421,6 +4442,10 @@
           </a:solidFill>
           <a:ln/>
         </p:spPr>
+        <p:txBody>
+          <a:bodyPr/>
+          <a:p/>
+        </p:txBody>
       </p:sp>
       <p:sp>
         <p:nvSpPr>
@@ -4575,6 +4600,10 @@
           </a:solidFill>
           <a:ln/>
         </p:spPr>
+        <p:txBody>
+          <a:bodyPr/>
+          <a:p/>
+        </p:txBody>
       </p:sp>
       <p:sp>
         <p:nvSpPr>
@@ -5165,6 +5194,10 @@
             <a:prstDash val="solid"/>
           </a:ln>
         </p:spPr>
+        <p:txBody>
+          <a:bodyPr/>
+          <a:p/>
+        </p:txBody>
       </p:sp>
       <p:sp>
         <p:nvSpPr>
@@ -5665,6 +5698,10 @@
           </a:solidFill>
           <a:ln/>
         </p:spPr>
+        <p:txBody>
+          <a:bodyPr/>
+          <a:p/>
+        </p:txBody>
       </p:sp>
       <p:sp>
         <p:nvSpPr>
@@ -6457,6 +6494,10 @@
             <a:prstDash val="solid"/>
           </a:ln>
         </p:spPr>
+        <p:txBody>
+          <a:bodyPr/>
+          <a:p/>
+        </p:txBody>
       </p:sp>
       <p:sp>
         <p:nvSpPr>
@@ -7147,45 +7188,7 @@
               <a:buNone/>
             </a:pPr>
             <a:r>
-              <a:rPr lang="en-US" sz="2700" b="1" i="0" dirty="0">
-                <a:solidFill>
-                  <a:srgbClr val="FAF8F5"/>
-                </a:solidFill>
-                <a:latin typeface="Georgia" pitchFamily="18" charset="0"/>
-                <a:ea typeface="Georgia" pitchFamily="18" charset="-122"/>
-                <a:cs typeface="Georgia" pitchFamily="18" charset="-120"/>
-              </a:rPr>
-              <a:t>Individual Contribution: Rohit </a:t>
-            </a:r>
-            <a:r>
-              <a:rPr lang="en-US" sz="2700" b="1" i="0" dirty="0" err="1">
-                <a:solidFill>
-                  <a:srgbClr val="FAF8F5"/>
-                </a:solidFill>
-                <a:latin typeface="Georgia" pitchFamily="18" charset="0"/>
-                <a:ea typeface="Georgia" pitchFamily="18" charset="-122"/>
-                <a:cs typeface="Georgia" pitchFamily="18" charset="-120"/>
-              </a:rPr>
-              <a:t>C</a:t>
-            </a:r>
-            <a:r>
-              <a:rPr lang="en-US" b="1" dirty="0" err="1">
-                <a:latin typeface="Georgia" pitchFamily="18" charset="0"/>
-                <a:ea typeface="Georgia" pitchFamily="18" charset="-122"/>
-                <a:cs typeface="Georgia" pitchFamily="18" charset="-120"/>
-              </a:rPr>
-              <a:t>hantiyal</a:t>
-            </a:r>
-            <a:r>
-              <a:rPr lang="en-US" sz="2700" b="1" i="0" dirty="0">
-                <a:solidFill>
-                  <a:srgbClr val="FAF8F5"/>
-                </a:solidFill>
-                <a:latin typeface="Georgia" pitchFamily="18" charset="0"/>
-                <a:ea typeface="Georgia" pitchFamily="18" charset="-122"/>
-                <a:cs typeface="Georgia" pitchFamily="18" charset="-120"/>
-              </a:rPr>
-              <a:t> (@Rohit-coder201)</a:t>
+              <a:t>Individual Contribution: Rohit Chhantiyal (@Rohit-coder201)</a:t>
             </a:r>
             <a:endParaRPr lang="en-US" sz="2700" dirty="0"/>
           </a:p>
@@ -7212,6 +7215,10 @@
           </a:solidFill>
           <a:ln/>
         </p:spPr>
+        <p:txBody>
+          <a:bodyPr/>
+          <a:p/>
+        </p:txBody>
       </p:sp>
       <p:sp>
         <p:nvSpPr>
@@ -7410,6 +7417,10 @@
           </a:solidFill>
           <a:ln/>
         </p:spPr>
+        <p:txBody>
+          <a:bodyPr/>
+          <a:p/>
+        </p:txBody>
       </p:sp>
       <p:sp>
         <p:nvSpPr>
@@ -7735,37 +7746,7 @@
               <a:buNone/>
             </a:pPr>
             <a:r>
-              <a:rPr lang="en-US" sz="1200" b="1" dirty="0">
-                <a:solidFill>
-                  <a:srgbClr val="1A1512"/>
-                </a:solidFill>
-                <a:latin typeface="Arial" pitchFamily="34" charset="0"/>
-                <a:ea typeface="Arial" pitchFamily="34" charset="-122"/>
-                <a:cs typeface="Arial" pitchFamily="34" charset="-120"/>
-              </a:rPr>
-              <a:t>Rohit </a:t>
-            </a:r>
-            <a:r>
-              <a:rPr lang="en-US" sz="1200" b="1" dirty="0" err="1">
-                <a:solidFill>
-                  <a:srgbClr val="1A1512"/>
-                </a:solidFill>
-                <a:latin typeface="Arial" pitchFamily="34" charset="0"/>
-                <a:ea typeface="Arial" pitchFamily="34" charset="-122"/>
-                <a:cs typeface="Arial" pitchFamily="34" charset="-120"/>
-              </a:rPr>
-              <a:t>Chantiyal</a:t>
-            </a:r>
-            <a:r>
-              <a:rPr lang="en-US" sz="1200" b="1" dirty="0">
-                <a:solidFill>
-                  <a:srgbClr val="1A1512"/>
-                </a:solidFill>
-                <a:latin typeface="Arial" pitchFamily="34" charset="0"/>
-                <a:ea typeface="Arial" pitchFamily="34" charset="-122"/>
-                <a:cs typeface="Arial" pitchFamily="34" charset="-120"/>
-              </a:rPr>
-              <a:t> · DevOps &amp; Resilience Lead</a:t>
+              <a:t>Rohit Chhantiyal · DevOps &amp; Resilience Lead</a:t>
             </a:r>
             <a:endParaRPr lang="en-US" sz="1200" dirty="0"/>
           </a:p>
@@ -7952,6 +7933,10 @@
             <a:prstDash val="solid"/>
           </a:ln>
         </p:spPr>
+        <p:txBody>
+          <a:bodyPr/>
+          <a:p/>
+        </p:txBody>
       </p:sp>
       <p:sp>
         <p:nvSpPr>
@@ -8199,6 +8184,10 @@
             <a:prstDash val="solid"/>
           </a:ln>
         </p:spPr>
+        <p:txBody>
+          <a:bodyPr/>
+          <a:p/>
+        </p:txBody>
       </p:sp>
       <p:sp>
         <p:nvSpPr>

</xml_diff>

<commit_message>
update presentation deck with new pptx and canonical name Rohit Chhantyal
</commit_message>
<xml_diff>
--- a/docs/week-07/BrewMellow_Midterm_Presentation.pptx
+++ b/docs/week-07/BrewMellow_Midterm_Presentation.pptx
@@ -2365,7 +2365,26 @@
               <a:buNone/>
             </a:pPr>
             <a:r>
-              <a:t>Rohit Chhantiyal</a:t>
+              <a:rPr lang="en-US" sz="1500" b="1" dirty="0">
+                <a:solidFill>
+                  <a:srgbClr val="FAF8F5"/>
+                </a:solidFill>
+                <a:latin typeface="Arial" pitchFamily="34" charset="0"/>
+                <a:ea typeface="Arial" pitchFamily="34" charset="-122"/>
+                <a:cs typeface="Arial" pitchFamily="34" charset="-120"/>
+              </a:rPr>
+              <a:t>Rohit </a:t>
+            </a:r>
+            <a:r>
+              <a:rPr lang="en-US" sz="1500" b="1" dirty="0" err="1">
+                <a:solidFill>
+                  <a:srgbClr val="FAF8F5"/>
+                </a:solidFill>
+                <a:latin typeface="Arial" pitchFamily="34" charset="0"/>
+                <a:ea typeface="Arial" pitchFamily="34" charset="-122"/>
+                <a:cs typeface="Arial" pitchFamily="34" charset="-120"/>
+              </a:rPr>
+              <a:t>Chhantyal</a:t>
             </a:r>
             <a:endParaRPr lang="en-US" sz="1500" dirty="0"/>
           </a:p>
@@ -3276,10 +3295,6 @@
             <a:prstDash val="solid"/>
           </a:ln>
         </p:spPr>
-        <p:txBody>
-          <a:bodyPr/>
-          <a:p/>
-        </p:txBody>
       </p:sp>
       <p:sp>
         <p:nvSpPr>
@@ -3615,10 +3630,6 @@
             <a:prstDash val="solid"/>
           </a:ln>
         </p:spPr>
-        <p:txBody>
-          <a:bodyPr/>
-          <a:p/>
-        </p:txBody>
       </p:sp>
       <p:sp>
         <p:nvSpPr>
@@ -4126,10 +4137,6 @@
           </a:solidFill>
           <a:ln/>
         </p:spPr>
-        <p:txBody>
-          <a:bodyPr/>
-          <a:p/>
-        </p:txBody>
       </p:sp>
       <p:sp>
         <p:nvSpPr>
@@ -4284,10 +4291,6 @@
           </a:solidFill>
           <a:ln/>
         </p:spPr>
-        <p:txBody>
-          <a:bodyPr/>
-          <a:p/>
-        </p:txBody>
       </p:sp>
       <p:sp>
         <p:nvSpPr>
@@ -4442,10 +4445,6 @@
           </a:solidFill>
           <a:ln/>
         </p:spPr>
-        <p:txBody>
-          <a:bodyPr/>
-          <a:p/>
-        </p:txBody>
       </p:sp>
       <p:sp>
         <p:nvSpPr>
@@ -4600,10 +4599,6 @@
           </a:solidFill>
           <a:ln/>
         </p:spPr>
-        <p:txBody>
-          <a:bodyPr/>
-          <a:p/>
-        </p:txBody>
       </p:sp>
       <p:sp>
         <p:nvSpPr>
@@ -5194,10 +5189,6 @@
             <a:prstDash val="solid"/>
           </a:ln>
         </p:spPr>
-        <p:txBody>
-          <a:bodyPr/>
-          <a:p/>
-        </p:txBody>
       </p:sp>
       <p:sp>
         <p:nvSpPr>
@@ -5698,10 +5689,6 @@
           </a:solidFill>
           <a:ln/>
         </p:spPr>
-        <p:txBody>
-          <a:bodyPr/>
-          <a:p/>
-        </p:txBody>
       </p:sp>
       <p:sp>
         <p:nvSpPr>
@@ -6494,10 +6481,6 @@
             <a:prstDash val="solid"/>
           </a:ln>
         </p:spPr>
-        <p:txBody>
-          <a:bodyPr/>
-          <a:p/>
-        </p:txBody>
       </p:sp>
       <p:sp>
         <p:nvSpPr>
@@ -7188,7 +7171,7 @@
               <a:buNone/>
             </a:pPr>
             <a:r>
-              <a:t>Individual Contribution: Rohit Chhantiyal (@Rohit-coder201)</a:t>
+              <a:t>Individual Contribution: Rohit Chhantyal (@Rohit-coder201)</a:t>
             </a:r>
             <a:endParaRPr lang="en-US" sz="2700" dirty="0"/>
           </a:p>
@@ -7746,7 +7729,37 @@
               <a:buNone/>
             </a:pPr>
             <a:r>
-              <a:t>Rohit Chhantiyal · DevOps &amp; Resilience Lead</a:t>
+              <a:rPr lang="en-US" sz="1200" b="1" dirty="0">
+                <a:solidFill>
+                  <a:srgbClr val="1A1512"/>
+                </a:solidFill>
+                <a:latin typeface="Arial" pitchFamily="34" charset="0"/>
+                <a:ea typeface="Arial" pitchFamily="34" charset="-122"/>
+                <a:cs typeface="Arial" pitchFamily="34" charset="-120"/>
+              </a:rPr>
+              <a:t>Rohit </a:t>
+            </a:r>
+            <a:r>
+              <a:rPr lang="en-US" sz="1200" b="1" dirty="0" err="1">
+                <a:solidFill>
+                  <a:srgbClr val="1A1512"/>
+                </a:solidFill>
+                <a:latin typeface="Arial" pitchFamily="34" charset="0"/>
+                <a:ea typeface="Arial" pitchFamily="34" charset="-122"/>
+                <a:cs typeface="Arial" pitchFamily="34" charset="-120"/>
+              </a:rPr>
+              <a:t>Chhantyal</a:t>
+            </a:r>
+            <a:r>
+              <a:rPr lang="en-US" sz="1200" b="1" dirty="0">
+                <a:solidFill>
+                  <a:srgbClr val="1A1512"/>
+                </a:solidFill>
+                <a:latin typeface="Arial" pitchFamily="34" charset="0"/>
+                <a:ea typeface="Arial" pitchFamily="34" charset="-122"/>
+                <a:cs typeface="Arial" pitchFamily="34" charset="-120"/>
+              </a:rPr>
+              <a:t> · DevOps &amp; Resilience Lead</a:t>
             </a:r>
             <a:endParaRPr lang="en-US" sz="1200" dirty="0"/>
           </a:p>
@@ -7933,10 +7946,6 @@
             <a:prstDash val="solid"/>
           </a:ln>
         </p:spPr>
-        <p:txBody>
-          <a:bodyPr/>
-          <a:p/>
-        </p:txBody>
       </p:sp>
       <p:sp>
         <p:nvSpPr>
@@ -8184,10 +8193,6 @@
             <a:prstDash val="solid"/>
           </a:ln>
         </p:spPr>
-        <p:txBody>
-          <a:bodyPr/>
-          <a:p/>
-        </p:txBody>
       </p:sp>
       <p:sp>
         <p:nvSpPr>

</xml_diff>

<commit_message>
fix header and slide name to Rohit Chhantyal in pptx
</commit_message>
<xml_diff>
--- a/docs/week-07/BrewMellow_Midterm_Presentation.pptx
+++ b/docs/week-07/BrewMellow_Midterm_Presentation.pptx
@@ -3295,6 +3295,10 @@
             <a:prstDash val="solid"/>
           </a:ln>
         </p:spPr>
+        <p:txBody>
+          <a:bodyPr/>
+          <a:p/>
+        </p:txBody>
       </p:sp>
       <p:sp>
         <p:nvSpPr>
@@ -3630,6 +3634,10 @@
             <a:prstDash val="solid"/>
           </a:ln>
         </p:spPr>
+        <p:txBody>
+          <a:bodyPr/>
+          <a:p/>
+        </p:txBody>
       </p:sp>
       <p:sp>
         <p:nvSpPr>
@@ -4137,6 +4145,10 @@
           </a:solidFill>
           <a:ln/>
         </p:spPr>
+        <p:txBody>
+          <a:bodyPr/>
+          <a:p/>
+        </p:txBody>
       </p:sp>
       <p:sp>
         <p:nvSpPr>
@@ -4291,6 +4303,10 @@
           </a:solidFill>
           <a:ln/>
         </p:spPr>
+        <p:txBody>
+          <a:bodyPr/>
+          <a:p/>
+        </p:txBody>
       </p:sp>
       <p:sp>
         <p:nvSpPr>
@@ -4445,6 +4461,10 @@
           </a:solidFill>
           <a:ln/>
         </p:spPr>
+        <p:txBody>
+          <a:bodyPr/>
+          <a:p/>
+        </p:txBody>
       </p:sp>
       <p:sp>
         <p:nvSpPr>
@@ -4599,6 +4619,10 @@
           </a:solidFill>
           <a:ln/>
         </p:spPr>
+        <p:txBody>
+          <a:bodyPr/>
+          <a:p/>
+        </p:txBody>
       </p:sp>
       <p:sp>
         <p:nvSpPr>
@@ -5189,6 +5213,10 @@
             <a:prstDash val="solid"/>
           </a:ln>
         </p:spPr>
+        <p:txBody>
+          <a:bodyPr/>
+          <a:p/>
+        </p:txBody>
       </p:sp>
       <p:sp>
         <p:nvSpPr>
@@ -5689,6 +5717,10 @@
           </a:solidFill>
           <a:ln/>
         </p:spPr>
+        <p:txBody>
+          <a:bodyPr/>
+          <a:p/>
+        </p:txBody>
       </p:sp>
       <p:sp>
         <p:nvSpPr>
@@ -6481,6 +6513,10 @@
             <a:prstDash val="solid"/>
           </a:ln>
         </p:spPr>
+        <p:txBody>
+          <a:bodyPr/>
+          <a:p/>
+        </p:txBody>
       </p:sp>
       <p:sp>
         <p:nvSpPr>
@@ -7946,6 +7982,10 @@
             <a:prstDash val="solid"/>
           </a:ln>
         </p:spPr>
+        <p:txBody>
+          <a:bodyPr/>
+          <a:p/>
+        </p:txBody>
       </p:sp>
       <p:sp>
         <p:nvSpPr>
@@ -8193,6 +8233,10 @@
             <a:prstDash val="solid"/>
           </a:ln>
         </p:spPr>
+        <p:txBody>
+          <a:bodyPr/>
+          <a:p/>
+        </p:txBody>
       </p:sp>
       <p:sp>
         <p:nvSpPr>

</xml_diff>